<commit_message>
docs: 同步 CLAUDE.md / PPT slide 23 反映 d94720d + 2753c3e
新加的東西(原本未在文件):
- ab_check_runs schema 加 lang/locale/channel 欄位(ALTER TABLE 自動 migrate)
- Resume 自動沿用 parent locale(start_run 讀 parent DB)
- UI 三處顯示 run-level locale(RunStatusBar / 進度行 / 歷史表)
- 平台驗收測試從 5 個變成 8 個

改動:
- CLAUDE.md Key Design Decisions:新加一條,描述 schema + resume inherit + UI 顯示位置
- docs/pptx-build/build.js slide #23 右欄:
  · 「平台驗收(5 個 pytest)」改成「平台驗收(8 個 pytest)」
  · Follow-up 拿掉「Resume 跨 locale 守門」,只剩 CLI flags
  · 新加區塊「Run-level locale 持久化」標示 schema + resume inherit
- docs/搜尋巡檢平台_功能操作_判斷邏輯_PR27.pptx:rebuild

PR description / Confluence 1969225751(v15)/ memory 也已對齊,不在 git。

Co-Authored-By: Claude Opus 4.7 (1M context) <noreply@anthropic.com>
</commit_message>
<xml_diff>
--- a/docs/搜尋巡檢平台_功能操作_判斷邏輯_PR27.pptx
+++ b/docs/搜尋巡檢平台_功能操作_判斷邏輯_PR27.pptx
@@ -16094,7 +16094,7 @@
                 <a:ea typeface="Microsoft JhengHei" pitchFamily="34" charset="-122"/>
                 <a:cs typeface="Microsoft JhengHei" pitchFamily="34" charset="-120"/>
               </a:rPr>
-              <a:t>平台驗收(5 個 pytest)</a:t>
+              <a:t>Run-level locale 持久化</a:t>
             </a:r>
             <a:endParaRPr lang="en-US" sz="1100" dirty="0"/>
           </a:p>
@@ -16114,7 +16114,7 @@
                 <a:ea typeface="Microsoft JhengHei" pitchFamily="34" charset="-122"/>
                 <a:cs typeface="Microsoft JhengHei" pitchFamily="34" charset="-120"/>
               </a:rPr>
-              <a:t>✓ v3 body 落地 lang/locale/channel</a:t>
+              <a:t>ab_check_runs schema 加 lang/locale/channel 欄位</a:t>
             </a:r>
             <a:endParaRPr lang="en-US" sz="1100" dirty="0"/>
           </a:p>
@@ -16126,15 +16126,15 @@
               <a:buNone/>
             </a:pPr>
             <a:r>
-              <a:rPr lang="en-US" sz="1000" dirty="0">
-                <a:solidFill>
-                  <a:srgbClr val="0F6E56"/>
-                </a:solidFill>
-                <a:latin typeface="Microsoft JhengHei" pitchFamily="34" charset="0"/>
-                <a:ea typeface="Microsoft JhengHei" pitchFamily="34" charset="-122"/>
-                <a:cs typeface="Microsoft JhengHei" pitchFamily="34" charset="-120"/>
-              </a:rPr>
-              <a:t>✓ 預設值與舊行為一致</a:t>
+              <a:rPr lang="en-US" sz="900" dirty="0">
+                <a:solidFill>
+                  <a:srgbClr val="888780"/>
+                </a:solidFill>
+                <a:latin typeface="Microsoft JhengHei" pitchFamily="34" charset="0"/>
+                <a:ea typeface="Microsoft JhengHei" pitchFamily="34" charset="-122"/>
+                <a:cs typeface="Microsoft JhengHei" pitchFamily="34" charset="-120"/>
+              </a:rPr>
+              <a:t>(既存 DB 走 ALTER TABLE 自動 migrate)</a:t>
             </a:r>
             <a:endParaRPr lang="en-US" sz="1100" dirty="0"/>
           </a:p>
@@ -16154,7 +16154,7 @@
                 <a:ea typeface="Microsoft JhengHei" pitchFamily="34" charset="-122"/>
                 <a:cs typeface="Microsoft JhengHei" pitchFamily="34" charset="-120"/>
               </a:rPr>
-              <a:t>✓ /api/unified-search forward</a:t>
+              <a:t>Resume 自動沿用 parent locale</a:t>
             </a:r>
             <a:endParaRPr lang="en-US" sz="1100" dirty="0"/>
           </a:p>
@@ -16166,15 +16166,15 @@
               <a:buNone/>
             </a:pPr>
             <a:r>
-              <a:rPr lang="en-US" sz="1000" dirty="0">
-                <a:solidFill>
-                  <a:srgbClr val="0F6E56"/>
-                </a:solidFill>
-                <a:latin typeface="Microsoft JhengHei" pitchFamily="34" charset="0"/>
-                <a:ea typeface="Microsoft JhengHei" pitchFamily="34" charset="-122"/>
-                <a:cs typeface="Microsoft JhengHei" pitchFamily="34" charset="-120"/>
-              </a:rPr>
-              <a:t>✓ /api/ab-check/start forward</a:t>
+              <a:rPr lang="en-US" sz="900" dirty="0">
+                <a:solidFill>
+                  <a:srgbClr val="888780"/>
+                </a:solidFill>
+                <a:latin typeface="Microsoft JhengHei" pitchFamily="34" charset="0"/>
+                <a:ea typeface="Microsoft JhengHei" pitchFamily="34" charset="-122"/>
+                <a:cs typeface="Microsoft JhengHei" pitchFamily="34" charset="-120"/>
+              </a:rPr>
+              <a:t>(start_run 讀 parent DB 蓋 caller)</a:t>
             </a:r>
             <a:endParaRPr lang="en-US" sz="1100" dirty="0"/>
           </a:p>
@@ -16186,15 +16186,15 @@
               <a:buNone/>
             </a:pPr>
             <a:r>
-              <a:rPr lang="en-US" sz="900" dirty="0">
-                <a:solidFill>
-                  <a:srgbClr val="888780"/>
-                </a:solidFill>
-                <a:latin typeface="Consolas" pitchFamily="34" charset="0"/>
-                <a:ea typeface="Consolas" pitchFamily="34" charset="-122"/>
-                <a:cs typeface="Consolas" pitchFamily="34" charset="-120"/>
-              </a:rPr>
-              <a:t>  test_i18n_channel_plumbing.py</a:t>
+              <a:rPr lang="en-US" sz="1100" dirty="0">
+                <a:solidFill>
+                  <a:srgbClr val="000000"/>
+                </a:solidFill>
+                <a:latin typeface="Microsoft JhengHei" pitchFamily="34" charset="0"/>
+                <a:ea typeface="Microsoft JhengHei" pitchFamily="34" charset="-122"/>
+                <a:cs typeface="Microsoft JhengHei" pitchFamily="34" charset="-120"/>
+              </a:rPr>
+              <a:t> </a:t>
             </a:r>
             <a:endParaRPr lang="en-US" sz="1100" dirty="0"/>
           </a:p>
@@ -16206,15 +16206,15 @@
               <a:buNone/>
             </a:pPr>
             <a:r>
-              <a:rPr lang="en-US" sz="1100" dirty="0">
-                <a:solidFill>
-                  <a:srgbClr val="000000"/>
-                </a:solidFill>
-                <a:latin typeface="Microsoft JhengHei" pitchFamily="34" charset="0"/>
-                <a:ea typeface="Microsoft JhengHei" pitchFamily="34" charset="-122"/>
-                <a:cs typeface="Microsoft JhengHei" pitchFamily="34" charset="-120"/>
-              </a:rPr>
-              <a:t> </a:t>
+              <a:rPr lang="en-US" sz="1100" b="1" dirty="0">
+                <a:solidFill>
+                  <a:srgbClr val="1A1A1A"/>
+                </a:solidFill>
+                <a:latin typeface="Microsoft JhengHei" pitchFamily="34" charset="0"/>
+                <a:ea typeface="Microsoft JhengHei" pitchFamily="34" charset="-122"/>
+                <a:cs typeface="Microsoft JhengHei" pitchFamily="34" charset="-120"/>
+              </a:rPr>
+              <a:t>平台驗收(8 個 pytest)</a:t>
             </a:r>
             <a:endParaRPr lang="en-US" sz="1100" dirty="0"/>
           </a:p>
@@ -16226,15 +16226,15 @@
               <a:buNone/>
             </a:pPr>
             <a:r>
-              <a:rPr lang="en-US" sz="1100" b="1" dirty="0">
-                <a:solidFill>
-                  <a:srgbClr val="854F0B"/>
-                </a:solidFill>
-                <a:latin typeface="Microsoft JhengHei" pitchFamily="34" charset="0"/>
-                <a:ea typeface="Microsoft JhengHei" pitchFamily="34" charset="-122"/>
-                <a:cs typeface="Microsoft JhengHei" pitchFamily="34" charset="-120"/>
-              </a:rPr>
-              <a:t>Follow-up(未進此 PR)</a:t>
+              <a:rPr lang="en-US" sz="1000" dirty="0">
+                <a:solidFill>
+                  <a:srgbClr val="0F6E56"/>
+                </a:solidFill>
+                <a:latin typeface="Microsoft JhengHei" pitchFamily="34" charset="0"/>
+                <a:ea typeface="Microsoft JhengHei" pitchFamily="34" charset="-122"/>
+                <a:cs typeface="Microsoft JhengHei" pitchFamily="34" charset="-120"/>
+              </a:rPr>
+              <a:t>✓ v3 body 落地 / 預設 fallback</a:t>
             </a:r>
             <a:endParaRPr lang="en-US" sz="1100" dirty="0"/>
           </a:p>
@@ -16246,7 +16246,67 @@
               <a:buNone/>
             </a:pPr>
             <a:r>
-              <a:rPr lang="en-US" sz="900" dirty="0">
+              <a:rPr lang="en-US" sz="1000" dirty="0">
+                <a:solidFill>
+                  <a:srgbClr val="0F6E56"/>
+                </a:solidFill>
+                <a:latin typeface="Microsoft JhengHei" pitchFamily="34" charset="0"/>
+                <a:ea typeface="Microsoft JhengHei" pitchFamily="34" charset="-122"/>
+                <a:cs typeface="Microsoft JhengHei" pitchFamily="34" charset="-120"/>
+              </a:rPr>
+              <a:t>✓ unified-search / ab-check forward</a:t>
+            </a:r>
+            <a:endParaRPr lang="en-US" sz="1100" dirty="0"/>
+          </a:p>
+          <a:p>
+            <a:pPr indent="0" marL="0">
+              <a:spcAft>
+                <a:spcPts val="100"/>
+              </a:spcAft>
+              <a:buNone/>
+            </a:pPr>
+            <a:r>
+              <a:rPr lang="en-US" sz="1000" dirty="0">
+                <a:solidFill>
+                  <a:srgbClr val="0F6E56"/>
+                </a:solidFill>
+                <a:latin typeface="Microsoft JhengHei" pitchFamily="34" charset="0"/>
+                <a:ea typeface="Microsoft JhengHei" pitchFamily="34" charset="-122"/>
+                <a:cs typeface="Microsoft JhengHei" pitchFamily="34" charset="-120"/>
+              </a:rPr>
+              <a:t>✓ DB 寫入 + 預設 + resume inherit</a:t>
+            </a:r>
+            <a:endParaRPr lang="en-US" sz="1100" dirty="0"/>
+          </a:p>
+          <a:p>
+            <a:pPr indent="0" marL="0">
+              <a:spcAft>
+                <a:spcPts val="100"/>
+              </a:spcAft>
+              <a:buNone/>
+            </a:pPr>
+            <a:r>
+              <a:rPr lang="en-US" sz="1100" dirty="0">
+                <a:solidFill>
+                  <a:srgbClr val="000000"/>
+                </a:solidFill>
+                <a:latin typeface="Microsoft JhengHei" pitchFamily="34" charset="0"/>
+                <a:ea typeface="Microsoft JhengHei" pitchFamily="34" charset="-122"/>
+                <a:cs typeface="Microsoft JhengHei" pitchFamily="34" charset="-120"/>
+              </a:rPr>
+              <a:t> </a:t>
+            </a:r>
+            <a:endParaRPr lang="en-US" sz="1100" dirty="0"/>
+          </a:p>
+          <a:p>
+            <a:pPr indent="0" marL="0">
+              <a:spcAft>
+                <a:spcPts val="100"/>
+              </a:spcAft>
+              <a:buNone/>
+            </a:pPr>
+            <a:r>
+              <a:rPr lang="en-US" sz="1100" b="1" dirty="0">
                 <a:solidFill>
                   <a:srgbClr val="854F0B"/>
                 </a:solidFill>
@@ -16254,7 +16314,7 @@
                 <a:ea typeface="Microsoft JhengHei" pitchFamily="34" charset="-122"/>
                 <a:cs typeface="Microsoft JhengHei" pitchFamily="34" charset="-120"/>
               </a:rPr>
-              <a:t>· Resume 跨 locale 守門(schema 需加欄位)</a:t>
+              <a:t>Follow-up(未進此 PR)</a:t>
             </a:r>
             <a:endParaRPr lang="en-US" sz="1100" dirty="0"/>
           </a:p>

</xml_diff>